<commit_message>
feat(pptx): --show-source puts each diagram's Mermaid source in a panel beside it
Opt-in (decks are for audiences); the source is XML-escaped (rule 2) and its font size is
fitted to the panel. Regenerates the verification decks with it.

Co-Authored-By: Claude Sonnet 5.5 <noreply@anthropic.com>
</commit_message>
<xml_diff>
--- a/test-corpus/word-verification/architecture-diagram.pptx
+++ b/test-corpus/word-verification/architecture-diagram.pptx
@@ -144,7 +144,7 @@
         </p:nvCxnSpPr>
         <p:spPr>
           <a:xfrm>
-            <a:off x="6663691" y="1870412"/>
+            <a:off x="4542283" y="1870412"/>
             <a:ext cx="1" cy="866468"/>
           </a:xfrm>
           <a:prstGeom prst="line">
@@ -167,7 +167,7 @@
         </p:nvCxnSpPr>
         <p:spPr>
           <a:xfrm flipH="1">
-            <a:off x="6130510" y="3281516"/>
+            <a:off x="4009102" y="3281516"/>
             <a:ext cx="405681" cy="866468"/>
           </a:xfrm>
           <a:prstGeom prst="line">
@@ -190,7 +190,7 @@
         </p:nvCxnSpPr>
         <p:spPr>
           <a:xfrm>
-            <a:off x="6791190" y="3281516"/>
+            <a:off x="4669782" y="3281516"/>
             <a:ext cx="492614" cy="1052139"/>
           </a:xfrm>
           <a:prstGeom prst="line">
@@ -212,7 +212,7 @@
         </p:nvCxnSpPr>
         <p:spPr>
           <a:xfrm>
-            <a:off x="7324373" y="4506949"/>
+            <a:off x="5202965" y="4506949"/>
             <a:ext cx="1" cy="1052139"/>
           </a:xfrm>
           <a:prstGeom prst="line">
@@ -234,7 +234,7 @@
         </p:nvSpPr>
         <p:spPr>
           <a:xfrm>
-            <a:off x="4401591" y="1325775"/>
+            <a:off x="2280183" y="1325775"/>
             <a:ext cx="1177159" cy="544637"/>
           </a:xfrm>
           <a:prstGeom prst="cloud">
@@ -280,7 +280,7 @@
         </p:nvSpPr>
         <p:spPr>
           <a:xfrm>
-            <a:off x="5387198" y="4147984"/>
+            <a:off x="3265790" y="4147984"/>
             <a:ext cx="1231621" cy="544637"/>
           </a:xfrm>
           <a:prstGeom prst="can">
@@ -326,7 +326,7 @@
         </p:nvSpPr>
         <p:spPr>
           <a:xfrm>
-            <a:off x="6230457" y="2736879"/>
+            <a:off x="4109049" y="2736879"/>
             <a:ext cx="866468" cy="544637"/>
           </a:xfrm>
           <a:prstGeom prst="roundRect">
@@ -372,7 +372,7 @@
         </p:nvSpPr>
         <p:spPr>
           <a:xfrm>
-            <a:off x="6858336" y="5559088"/>
+            <a:off x="4736928" y="5559088"/>
             <a:ext cx="932072" cy="544637"/>
           </a:xfrm>
           <a:prstGeom prst="can">
@@ -418,7 +418,7 @@
         </p:nvSpPr>
         <p:spPr>
           <a:xfrm>
-            <a:off x="6197656" y="1325775"/>
+            <a:off x="4076248" y="1325775"/>
             <a:ext cx="932072" cy="544637"/>
           </a:xfrm>
           <a:prstGeom prst="roundRect">
@@ -464,7 +464,7 @@
         </p:nvSpPr>
         <p:spPr>
           <a:xfrm>
-            <a:off x="7237726" y="4333656"/>
+            <a:off x="5116318" y="4333656"/>
             <a:ext cx="173294" cy="173294"/>
           </a:xfrm>
           <a:prstGeom prst="ellipse">
@@ -474,6 +474,185 @@
             <a:srgbClr val="2F5496"/>
           </a:solidFill>
         </p:spPr>
+      </p:sp>
+      <p:sp>
+        <p:nvSpPr>
+          <p:cNvPr id="4" name="Mermaid source"/>
+          <p:cNvSpPr/>
+          <p:nvPr/>
+        </p:nvSpPr>
+        <p:spPr>
+          <a:xfrm>
+            <a:off x="7674864" y="1028700"/>
+            <a:ext cx="4059936" cy="5372100"/>
+          </a:xfrm>
+          <a:prstGeom prst="rect">
+            <a:avLst/>
+          </a:prstGeom>
+          <a:solidFill>
+            <a:srgbClr val="F3F4F6"/>
+          </a:solidFill>
+          <a:ln w="9525">
+            <a:solidFill>
+              <a:srgbClr val="D1D5DB"/>
+            </a:solidFill>
+          </a:ln>
+        </p:spPr>
+        <p:txBody>
+          <a:bodyPr wrap="square" lIns="91440" tIns="45720" rIns="91440" bIns="45720" anchor="t">
+            <a:noAutofit/>
+          </a:bodyPr>
+          <a:lstStyle/>
+          <a:p>
+            <a:pPr algn="l"/>
+            <a:r>
+              <a:rPr lang="en-US" sz="1400" dirty="0">
+                <a:solidFill>
+                  <a:srgbClr val="1F2937"/>
+                </a:solidFill>
+                <a:latin typeface="Consolas"/>
+                <a:cs typeface="Consolas"/>
+              </a:rPr>
+              <a:t>architecture-beta</a:t>
+            </a:r>
+          </a:p>
+          <a:p>
+            <a:pPr algn="l"/>
+            <a:r>
+              <a:rPr lang="en-US" sz="1400" dirty="0">
+                <a:solidFill>
+                  <a:srgbClr val="1F2937"/>
+                </a:solidFill>
+                <a:latin typeface="Consolas"/>
+                <a:cs typeface="Consolas"/>
+              </a:rPr>
+              <a:t>  group public_api(cloud)[Public API]</a:t>
+            </a:r>
+          </a:p>
+          <a:p>
+            <a:endParaRPr lang="en-US" sz="1400" dirty="0"/>
+          </a:p>
+          <a:p>
+            <a:pPr algn="l"/>
+            <a:r>
+              <a:rPr lang="en-US" sz="1400" dirty="0">
+                <a:solidFill>
+                  <a:srgbClr val="1F2937"/>
+                </a:solidFill>
+                <a:latin typeface="Consolas"/>
+                <a:cs typeface="Consolas"/>
+              </a:rPr>
+              <a:t>  service database1(database)[My Database] in public_api</a:t>
+            </a:r>
+          </a:p>
+          <a:p>
+            <a:pPr algn="l"/>
+            <a:r>
+              <a:rPr lang="en-US" sz="1400" dirty="0">
+                <a:solidFill>
+                  <a:srgbClr val="1F2937"/>
+                </a:solidFill>
+                <a:latin typeface="Consolas"/>
+                <a:cs typeface="Consolas"/>
+              </a:rPr>
+              <a:t>  service server(server)[Server] in public_api</a:t>
+            </a:r>
+          </a:p>
+          <a:p>
+            <a:pPr algn="l"/>
+            <a:r>
+              <a:rPr lang="en-US" sz="1400" dirty="0">
+                <a:solidFill>
+                  <a:srgbClr val="1F2937"/>
+                </a:solidFill>
+                <a:latin typeface="Consolas"/>
+                <a:cs typeface="Consolas"/>
+              </a:rPr>
+              <a:t>  service disk1(disk)[Storage] in public_api</a:t>
+            </a:r>
+          </a:p>
+          <a:p>
+            <a:pPr algn="l"/>
+            <a:r>
+              <a:rPr lang="en-US" sz="1400" dirty="0">
+                <a:solidFill>
+                  <a:srgbClr val="1F2937"/>
+                </a:solidFill>
+                <a:latin typeface="Consolas"/>
+                <a:cs typeface="Consolas"/>
+              </a:rPr>
+              <a:t>  service gateway(internet)[Gateway]</a:t>
+            </a:r>
+          </a:p>
+          <a:p>
+            <a:pPr algn="l"/>
+            <a:r>
+              <a:rPr lang="en-US" sz="1400" dirty="0">
+                <a:solidFill>
+                  <a:srgbClr val="1F2937"/>
+                </a:solidFill>
+                <a:latin typeface="Consolas"/>
+                <a:cs typeface="Consolas"/>
+              </a:rPr>
+              <a:t>  junction j1</a:t>
+            </a:r>
+          </a:p>
+          <a:p>
+            <a:endParaRPr lang="en-US" sz="1400" dirty="0"/>
+          </a:p>
+          <a:p>
+            <a:pPr algn="l"/>
+            <a:r>
+              <a:rPr lang="en-US" sz="1400" dirty="0">
+                <a:solidFill>
+                  <a:srgbClr val="1F2937"/>
+                </a:solidFill>
+                <a:latin typeface="Consolas"/>
+                <a:cs typeface="Consolas"/>
+              </a:rPr>
+              <a:t>  gateway:B --&gt; T:server</a:t>
+            </a:r>
+          </a:p>
+          <a:p>
+            <a:pPr algn="l"/>
+            <a:r>
+              <a:rPr lang="en-US" sz="1400" dirty="0">
+                <a:solidFill>
+                  <a:srgbClr val="1F2937"/>
+                </a:solidFill>
+                <a:latin typeface="Consolas"/>
+                <a:cs typeface="Consolas"/>
+              </a:rPr>
+              <a:t>  server:R --&gt; L:database1</a:t>
+            </a:r>
+          </a:p>
+          <a:p>
+            <a:pPr algn="l"/>
+            <a:r>
+              <a:rPr lang="en-US" sz="1400" dirty="0">
+                <a:solidFill>
+                  <a:srgbClr val="1F2937"/>
+                </a:solidFill>
+                <a:latin typeface="Consolas"/>
+                <a:cs typeface="Consolas"/>
+              </a:rPr>
+              <a:t>  server:B -- T:j1</a:t>
+            </a:r>
+          </a:p>
+          <a:p>
+            <a:pPr algn="l"/>
+            <a:r>
+              <a:rPr lang="en-US" sz="1400" dirty="0">
+                <a:solidFill>
+                  <a:srgbClr val="1F2937"/>
+                </a:solidFill>
+                <a:latin typeface="Consolas"/>
+                <a:cs typeface="Consolas"/>
+              </a:rPr>
+              <a:t>  j1:R -- L:disk1</a:t>
+            </a:r>
+          </a:p>
+        </p:txBody>
       </p:sp>
     </p:spTree>
   </p:cSld>

</xml_diff>